<commit_message>
Plot color update, yaml file update
</commit_message>
<xml_diff>
--- a/figures/edited/fig3_edited.pptx
+++ b/figures/edited/fig3_edited.pptx
@@ -197,7 +197,7 @@
           <a:p>
             <a:fld id="{48468050-661E-AB4B-B42D-BE017D866B74}" type="datetimeFigureOut">
               <a:rPr lang="en-US" smtClean="0"/>
-              <a:t>6/1/26</a:t>
+              <a:t>6/18/26</a:t>
             </a:fld>
             <a:endParaRPr lang="en-US"/>
           </a:p>
@@ -679,7 +679,7 @@
           <a:p>
             <a:fld id="{F0AF5F10-C112-A742-9AF3-53C7C1FC7211}" type="datetimeFigureOut">
               <a:rPr lang="en-US" smtClean="0"/>
-              <a:t>6/1/26</a:t>
+              <a:t>6/18/26</a:t>
             </a:fld>
             <a:endParaRPr lang="en-US"/>
           </a:p>
@@ -849,7 +849,7 @@
           <a:p>
             <a:fld id="{F0AF5F10-C112-A742-9AF3-53C7C1FC7211}" type="datetimeFigureOut">
               <a:rPr lang="en-US" smtClean="0"/>
-              <a:t>6/1/26</a:t>
+              <a:t>6/18/26</a:t>
             </a:fld>
             <a:endParaRPr lang="en-US"/>
           </a:p>
@@ -1029,7 +1029,7 @@
           <a:p>
             <a:fld id="{F0AF5F10-C112-A742-9AF3-53C7C1FC7211}" type="datetimeFigureOut">
               <a:rPr lang="en-US" smtClean="0"/>
-              <a:t>6/1/26</a:t>
+              <a:t>6/18/26</a:t>
             </a:fld>
             <a:endParaRPr lang="en-US"/>
           </a:p>
@@ -1199,7 +1199,7 @@
           <a:p>
             <a:fld id="{F0AF5F10-C112-A742-9AF3-53C7C1FC7211}" type="datetimeFigureOut">
               <a:rPr lang="en-US" smtClean="0"/>
-              <a:t>6/1/26</a:t>
+              <a:t>6/18/26</a:t>
             </a:fld>
             <a:endParaRPr lang="en-US"/>
           </a:p>
@@ -1445,7 +1445,7 @@
           <a:p>
             <a:fld id="{F0AF5F10-C112-A742-9AF3-53C7C1FC7211}" type="datetimeFigureOut">
               <a:rPr lang="en-US" smtClean="0"/>
-              <a:t>6/1/26</a:t>
+              <a:t>6/18/26</a:t>
             </a:fld>
             <a:endParaRPr lang="en-US"/>
           </a:p>
@@ -1677,7 +1677,7 @@
           <a:p>
             <a:fld id="{F0AF5F10-C112-A742-9AF3-53C7C1FC7211}" type="datetimeFigureOut">
               <a:rPr lang="en-US" smtClean="0"/>
-              <a:t>6/1/26</a:t>
+              <a:t>6/18/26</a:t>
             </a:fld>
             <a:endParaRPr lang="en-US"/>
           </a:p>
@@ -2044,7 +2044,7 @@
           <a:p>
             <a:fld id="{F0AF5F10-C112-A742-9AF3-53C7C1FC7211}" type="datetimeFigureOut">
               <a:rPr lang="en-US" smtClean="0"/>
-              <a:t>6/1/26</a:t>
+              <a:t>6/18/26</a:t>
             </a:fld>
             <a:endParaRPr lang="en-US"/>
           </a:p>
@@ -2162,7 +2162,7 @@
           <a:p>
             <a:fld id="{F0AF5F10-C112-A742-9AF3-53C7C1FC7211}" type="datetimeFigureOut">
               <a:rPr lang="en-US" smtClean="0"/>
-              <a:t>6/1/26</a:t>
+              <a:t>6/18/26</a:t>
             </a:fld>
             <a:endParaRPr lang="en-US"/>
           </a:p>
@@ -2257,7 +2257,7 @@
           <a:p>
             <a:fld id="{F0AF5F10-C112-A742-9AF3-53C7C1FC7211}" type="datetimeFigureOut">
               <a:rPr lang="en-US" smtClean="0"/>
-              <a:t>6/1/26</a:t>
+              <a:t>6/18/26</a:t>
             </a:fld>
             <a:endParaRPr lang="en-US"/>
           </a:p>
@@ -2534,7 +2534,7 @@
           <a:p>
             <a:fld id="{F0AF5F10-C112-A742-9AF3-53C7C1FC7211}" type="datetimeFigureOut">
               <a:rPr lang="en-US" smtClean="0"/>
-              <a:t>6/1/26</a:t>
+              <a:t>6/18/26</a:t>
             </a:fld>
             <a:endParaRPr lang="en-US"/>
           </a:p>
@@ -2791,7 +2791,7 @@
           <a:p>
             <a:fld id="{F0AF5F10-C112-A742-9AF3-53C7C1FC7211}" type="datetimeFigureOut">
               <a:rPr lang="en-US" smtClean="0"/>
-              <a:t>6/1/26</a:t>
+              <a:t>6/18/26</a:t>
             </a:fld>
             <a:endParaRPr lang="en-US"/>
           </a:p>
@@ -3004,7 +3004,7 @@
           <a:p>
             <a:fld id="{F0AF5F10-C112-A742-9AF3-53C7C1FC7211}" type="datetimeFigureOut">
               <a:rPr lang="en-US" smtClean="0"/>
-              <a:t>6/1/26</a:t>
+              <a:t>6/18/26</a:t>
             </a:fld>
             <a:endParaRPr lang="en-US"/>
           </a:p>
@@ -3545,10 +3545,7 @@
             </a:solidFill>
             <a:ln w="15875">
               <a:solidFill>
-                <a:schemeClr val="tx1">
-                  <a:lumMod val="65000"/>
-                  <a:lumOff val="35000"/>
-                </a:schemeClr>
+                <a:schemeClr val="accent1"/>
               </a:solidFill>
             </a:ln>
           </p:spPr>
@@ -3679,10 +3676,7 @@
             </a:solidFill>
             <a:ln w="15875">
               <a:solidFill>
-                <a:schemeClr val="tx1">
-                  <a:lumMod val="65000"/>
-                  <a:lumOff val="35000"/>
-                </a:schemeClr>
+                <a:schemeClr val="accent1"/>
               </a:solidFill>
             </a:ln>
           </p:spPr>
@@ -4295,7 +4289,7 @@
                   <a:rPr lang="en-US" sz="800" dirty="0">
                     <a:latin typeface="Helvetica" pitchFamily="2" charset="0"/>
                   </a:rPr>
-                  <a:t>Transconjugant Selection</a:t>
+                  <a:t>Transconjugant Selection Phase</a:t>
                 </a:r>
               </a:p>
             </p:txBody>
@@ -4549,15 +4543,10 @@
                     </a:pathLst>
                   </a:custGeom>
                   <a:solidFill>
-                    <a:srgbClr val="FEF1CF"/>
+                    <a:schemeClr val="accent6"/>
                   </a:solidFill>
                   <a:ln w="15875">
-                    <a:solidFill>
-                      <a:schemeClr val="tx1">
-                        <a:lumMod val="65000"/>
-                        <a:lumOff val="35000"/>
-                      </a:schemeClr>
-                    </a:solidFill>
+                    <a:noFill/>
                   </a:ln>
                 </p:spPr>
                 <p:style>
@@ -4931,9 +4920,9 @@
               <p:grpSpPr>
                 <a:xfrm>
                   <a:off x="350862" y="1615390"/>
-                  <a:ext cx="241267" cy="561885"/>
+                  <a:ext cx="238042" cy="561885"/>
                   <a:chOff x="461789" y="737337"/>
-                  <a:chExt cx="582555" cy="1337377"/>
+                  <a:chExt cx="574772" cy="1337377"/>
                 </a:xfrm>
               </p:grpSpPr>
               <p:grpSp>
@@ -5724,9 +5713,9 @@
                 </p:nvGrpSpPr>
                 <p:grpSpPr>
                   <a:xfrm rot="8575568">
-                    <a:off x="738670" y="1662940"/>
+                    <a:off x="730887" y="1685784"/>
                     <a:ext cx="305674" cy="180810"/>
-                    <a:chOff x="7196230" y="4833936"/>
+                    <a:chOff x="7290448" y="4770125"/>
                     <a:chExt cx="1441360" cy="852584"/>
                   </a:xfrm>
                 </p:grpSpPr>
@@ -5744,7 +5733,7 @@
                   </p:nvSpPr>
                   <p:spPr>
                     <a:xfrm>
-                      <a:off x="7196230" y="4833936"/>
+                      <a:off x="7290448" y="4770125"/>
                       <a:ext cx="1441360" cy="852584"/>
                     </a:xfrm>
                     <a:prstGeom prst="roundRect">
@@ -5800,8 +5789,8 @@
                   </p:nvSpPr>
                   <p:spPr>
                     <a:xfrm>
-                      <a:off x="7975495" y="5001222"/>
-                      <a:ext cx="488623" cy="488623"/>
+                      <a:off x="8069486" y="4937706"/>
+                      <a:ext cx="488624" cy="488621"/>
                     </a:xfrm>
                     <a:prstGeom prst="ellipse">
                       <a:avLst/>
@@ -6206,7 +6195,9 @@
                   <a:prstGeom prst="ellipse">
                     <a:avLst/>
                   </a:prstGeom>
-                  <a:grpFill/>
+                  <a:solidFill>
+                    <a:schemeClr val="accent6"/>
+                  </a:solidFill>
                   <a:ln w="15875">
                     <a:solidFill>
                       <a:schemeClr val="tx1">
@@ -6261,7 +6252,9 @@
                   <a:prstGeom prst="ellipse">
                     <a:avLst/>
                   </a:prstGeom>
-                  <a:grpFill/>
+                  <a:solidFill>
+                    <a:schemeClr val="accent6"/>
+                  </a:solidFill>
                   <a:ln w="15875">
                     <a:solidFill>
                       <a:schemeClr val="tx1">
@@ -6935,8 +6928,8 @@
                 <a:ln w="15875">
                   <a:solidFill>
                     <a:schemeClr val="tx1">
-                      <a:lumMod val="50000"/>
-                      <a:lumOff val="50000"/>
+                      <a:lumMod val="65000"/>
+                      <a:lumOff val="35000"/>
                     </a:schemeClr>
                   </a:solidFill>
                 </a:ln>
@@ -6992,8 +6985,8 @@
                 <a:ln w="15875">
                   <a:solidFill>
                     <a:schemeClr val="tx1">
-                      <a:lumMod val="50000"/>
-                      <a:lumOff val="50000"/>
+                      <a:lumMod val="65000"/>
+                      <a:lumOff val="35000"/>
                     </a:schemeClr>
                   </a:solidFill>
                 </a:ln>
@@ -7929,15 +7922,10 @@
                     </a:pathLst>
                   </a:custGeom>
                   <a:solidFill>
-                    <a:srgbClr val="FEF1CF"/>
+                    <a:schemeClr val="accent6"/>
                   </a:solidFill>
                   <a:ln w="15875">
-                    <a:solidFill>
-                      <a:schemeClr val="tx1">
-                        <a:lumMod val="65000"/>
-                        <a:lumOff val="35000"/>
-                      </a:schemeClr>
-                    </a:solidFill>
+                    <a:noFill/>
                   </a:ln>
                 </p:spPr>
                 <p:style>
@@ -9028,15 +9016,10 @@
                     </a:pathLst>
                   </a:custGeom>
                   <a:solidFill>
-                    <a:srgbClr val="FEF1CF"/>
+                    <a:schemeClr val="accent6"/>
                   </a:solidFill>
                   <a:ln w="15875">
-                    <a:solidFill>
-                      <a:schemeClr val="tx1">
-                        <a:lumMod val="65000"/>
-                        <a:lumOff val="35000"/>
-                      </a:schemeClr>
-                    </a:solidFill>
+                    <a:noFill/>
                   </a:ln>
                 </p:spPr>
                 <p:style>
@@ -9410,9 +9393,9 @@
               <p:grpSpPr>
                 <a:xfrm>
                   <a:off x="350862" y="1615390"/>
-                  <a:ext cx="241267" cy="561885"/>
+                  <a:ext cx="238042" cy="561885"/>
                   <a:chOff x="461789" y="737337"/>
-                  <a:chExt cx="582555" cy="1337377"/>
+                  <a:chExt cx="574772" cy="1337377"/>
                 </a:xfrm>
               </p:grpSpPr>
               <p:grpSp>
@@ -10203,9 +10186,9 @@
                 </p:nvGrpSpPr>
                 <p:grpSpPr>
                   <a:xfrm rot="8575568">
-                    <a:off x="738670" y="1662940"/>
+                    <a:off x="730887" y="1685784"/>
                     <a:ext cx="305674" cy="180810"/>
-                    <a:chOff x="7196230" y="4833936"/>
+                    <a:chOff x="7290448" y="4770125"/>
                     <a:chExt cx="1441360" cy="852584"/>
                   </a:xfrm>
                 </p:grpSpPr>
@@ -10223,7 +10206,7 @@
                   </p:nvSpPr>
                   <p:spPr>
                     <a:xfrm>
-                      <a:off x="7196230" y="4833936"/>
+                      <a:off x="7290448" y="4770125"/>
                       <a:ext cx="1441360" cy="852584"/>
                     </a:xfrm>
                     <a:prstGeom prst="roundRect">
@@ -10279,8 +10262,8 @@
                   </p:nvSpPr>
                   <p:spPr>
                     <a:xfrm>
-                      <a:off x="7975495" y="5001222"/>
-                      <a:ext cx="488623" cy="488623"/>
+                      <a:off x="8069515" y="4937967"/>
+                      <a:ext cx="488624" cy="488621"/>
                     </a:xfrm>
                     <a:prstGeom prst="ellipse">
                       <a:avLst/>
@@ -10646,12 +10629,7 @@
                     <a:srgbClr val="F5F2FF"/>
                   </a:solidFill>
                   <a:ln w="15875">
-                    <a:solidFill>
-                      <a:schemeClr val="tx1">
-                        <a:lumMod val="65000"/>
-                        <a:lumOff val="35000"/>
-                      </a:schemeClr>
-                    </a:solidFill>
+                    <a:noFill/>
                   </a:ln>
                 </p:spPr>
                 <p:style>
@@ -11025,9 +11003,9 @@
               <p:grpSpPr>
                 <a:xfrm>
                   <a:off x="350862" y="1615390"/>
-                  <a:ext cx="241267" cy="561885"/>
+                  <a:ext cx="238042" cy="561885"/>
                   <a:chOff x="461789" y="737337"/>
-                  <a:chExt cx="582555" cy="1337377"/>
+                  <a:chExt cx="574772" cy="1337377"/>
                 </a:xfrm>
               </p:grpSpPr>
               <p:grpSp>
@@ -11073,7 +11051,9 @@
                       </a:avLst>
                     </a:prstGeom>
                     <a:solidFill>
-                      <a:schemeClr val="bg2"/>
+                      <a:schemeClr val="bg1">
+                        <a:lumMod val="85000"/>
+                      </a:schemeClr>
                     </a:solidFill>
                     <a:ln w="9525">
                       <a:solidFill>
@@ -11202,7 +11182,9 @@
                       </a:avLst>
                     </a:prstGeom>
                     <a:solidFill>
-                      <a:schemeClr val="bg2"/>
+                      <a:schemeClr val="bg1">
+                        <a:lumMod val="85000"/>
+                      </a:schemeClr>
                     </a:solidFill>
                     <a:ln w="9525">
                       <a:solidFill>
@@ -11331,7 +11313,9 @@
                       </a:avLst>
                     </a:prstGeom>
                     <a:solidFill>
-                      <a:schemeClr val="bg2"/>
+                      <a:schemeClr val="bg1">
+                        <a:lumMod val="85000"/>
+                      </a:schemeClr>
                     </a:solidFill>
                     <a:ln w="9525">
                       <a:solidFill>
@@ -11460,7 +11444,9 @@
                       </a:avLst>
                     </a:prstGeom>
                     <a:solidFill>
-                      <a:schemeClr val="bg2"/>
+                      <a:schemeClr val="bg1">
+                        <a:lumMod val="85000"/>
+                      </a:schemeClr>
                     </a:solidFill>
                     <a:ln w="9525">
                       <a:solidFill>
@@ -11589,7 +11575,9 @@
                       </a:avLst>
                     </a:prstGeom>
                     <a:solidFill>
-                      <a:schemeClr val="bg2"/>
+                      <a:schemeClr val="bg1">
+                        <a:lumMod val="85000"/>
+                      </a:schemeClr>
                     </a:solidFill>
                     <a:ln w="9525">
                       <a:solidFill>
@@ -11718,7 +11706,9 @@
                       </a:avLst>
                     </a:prstGeom>
                     <a:solidFill>
-                      <a:schemeClr val="bg2"/>
+                      <a:schemeClr val="bg1">
+                        <a:lumMod val="85000"/>
+                      </a:schemeClr>
                     </a:solidFill>
                     <a:ln w="9525">
                       <a:solidFill>
@@ -11818,9 +11808,9 @@
                 </p:nvGrpSpPr>
                 <p:grpSpPr>
                   <a:xfrm rot="8575568">
-                    <a:off x="738670" y="1662940"/>
+                    <a:off x="730887" y="1685784"/>
                     <a:ext cx="305674" cy="180810"/>
-                    <a:chOff x="7196230" y="4833936"/>
+                    <a:chOff x="7290448" y="4770125"/>
                     <a:chExt cx="1441360" cy="852584"/>
                   </a:xfrm>
                 </p:grpSpPr>
@@ -11838,7 +11828,7 @@
                   </p:nvSpPr>
                   <p:spPr>
                     <a:xfrm>
-                      <a:off x="7196230" y="4833936"/>
+                      <a:off x="7290448" y="4770125"/>
                       <a:ext cx="1441360" cy="852584"/>
                     </a:xfrm>
                     <a:prstGeom prst="roundRect">
@@ -11847,7 +11837,9 @@
                       </a:avLst>
                     </a:prstGeom>
                     <a:solidFill>
-                      <a:schemeClr val="bg2"/>
+                      <a:schemeClr val="bg1">
+                        <a:lumMod val="85000"/>
+                      </a:schemeClr>
                     </a:solidFill>
                     <a:ln w="9525">
                       <a:solidFill>
@@ -11894,8 +11886,8 @@
                   </p:nvSpPr>
                   <p:spPr>
                     <a:xfrm>
-                      <a:off x="7975495" y="5001222"/>
-                      <a:ext cx="488623" cy="488623"/>
+                      <a:off x="8069713" y="4937410"/>
+                      <a:ext cx="488624" cy="488621"/>
                     </a:xfrm>
                     <a:prstGeom prst="ellipse">
                       <a:avLst/>
@@ -11976,7 +11968,9 @@
                       </a:avLst>
                     </a:prstGeom>
                     <a:solidFill>
-                      <a:schemeClr val="bg2"/>
+                      <a:schemeClr val="bg1">
+                        <a:lumMod val="85000"/>
+                      </a:schemeClr>
                     </a:solidFill>
                     <a:ln w="9525">
                       <a:solidFill>
@@ -12772,10 +12766,7 @@
             </a:solidFill>
             <a:ln w="15875">
               <a:solidFill>
-                <a:schemeClr val="tx1">
-                  <a:lumMod val="65000"/>
-                  <a:lumOff val="35000"/>
-                </a:schemeClr>
+                <a:schemeClr val="accent2"/>
               </a:solidFill>
             </a:ln>
           </p:spPr>
@@ -12818,8 +12809,8 @@
           </p:nvSpPr>
           <p:spPr>
             <a:xfrm>
-              <a:off x="7975495" y="5001222"/>
-              <a:ext cx="488623" cy="488623"/>
+              <a:off x="7975493" y="5026880"/>
+              <a:ext cx="488621" cy="488626"/>
             </a:xfrm>
             <a:prstGeom prst="ellipse">
               <a:avLst/>
@@ -13057,16 +13048,16 @@
         <a:srgbClr val="8294F5"/>
       </a:accent2>
       <a:accent3>
-        <a:srgbClr val="E6E9FC"/>
+        <a:srgbClr val="E7E8FC"/>
       </a:accent3>
       <a:accent4>
-        <a:srgbClr val="C3BAEB"/>
+        <a:srgbClr val="CBADEA"/>
       </a:accent4>
       <a:accent5>
-        <a:srgbClr val="D8AACE"/>
+        <a:srgbClr val="F5C3EF"/>
       </a:accent5>
       <a:accent6>
-        <a:srgbClr val="4EA72E"/>
+        <a:srgbClr val="FEEEBC"/>
       </a:accent6>
       <a:hlink>
         <a:srgbClr val="467886"/>

</xml_diff>

<commit_message>
Update pipeline, add fig S4
</commit_message>
<xml_diff>
--- a/figures/edited/fig3_edited.pptx
+++ b/figures/edited/fig3_edited.pptx
@@ -197,7 +197,7 @@
           <a:p>
             <a:fld id="{48468050-661E-AB4B-B42D-BE017D866B74}" type="datetimeFigureOut">
               <a:rPr lang="en-US" smtClean="0"/>
-              <a:t>7/2/26</a:t>
+              <a:t>7/15/26</a:t>
             </a:fld>
             <a:endParaRPr lang="en-US"/>
           </a:p>
@@ -679,7 +679,7 @@
           <a:p>
             <a:fld id="{F0AF5F10-C112-A742-9AF3-53C7C1FC7211}" type="datetimeFigureOut">
               <a:rPr lang="en-US" smtClean="0"/>
-              <a:t>7/2/26</a:t>
+              <a:t>7/15/26</a:t>
             </a:fld>
             <a:endParaRPr lang="en-US"/>
           </a:p>
@@ -849,7 +849,7 @@
           <a:p>
             <a:fld id="{F0AF5F10-C112-A742-9AF3-53C7C1FC7211}" type="datetimeFigureOut">
               <a:rPr lang="en-US" smtClean="0"/>
-              <a:t>7/2/26</a:t>
+              <a:t>7/15/26</a:t>
             </a:fld>
             <a:endParaRPr lang="en-US"/>
           </a:p>
@@ -1029,7 +1029,7 @@
           <a:p>
             <a:fld id="{F0AF5F10-C112-A742-9AF3-53C7C1FC7211}" type="datetimeFigureOut">
               <a:rPr lang="en-US" smtClean="0"/>
-              <a:t>7/2/26</a:t>
+              <a:t>7/15/26</a:t>
             </a:fld>
             <a:endParaRPr lang="en-US"/>
           </a:p>
@@ -1199,7 +1199,7 @@
           <a:p>
             <a:fld id="{F0AF5F10-C112-A742-9AF3-53C7C1FC7211}" type="datetimeFigureOut">
               <a:rPr lang="en-US" smtClean="0"/>
-              <a:t>7/2/26</a:t>
+              <a:t>7/15/26</a:t>
             </a:fld>
             <a:endParaRPr lang="en-US"/>
           </a:p>
@@ -1445,7 +1445,7 @@
           <a:p>
             <a:fld id="{F0AF5F10-C112-A742-9AF3-53C7C1FC7211}" type="datetimeFigureOut">
               <a:rPr lang="en-US" smtClean="0"/>
-              <a:t>7/2/26</a:t>
+              <a:t>7/15/26</a:t>
             </a:fld>
             <a:endParaRPr lang="en-US"/>
           </a:p>
@@ -1677,7 +1677,7 @@
           <a:p>
             <a:fld id="{F0AF5F10-C112-A742-9AF3-53C7C1FC7211}" type="datetimeFigureOut">
               <a:rPr lang="en-US" smtClean="0"/>
-              <a:t>7/2/26</a:t>
+              <a:t>7/15/26</a:t>
             </a:fld>
             <a:endParaRPr lang="en-US"/>
           </a:p>
@@ -2044,7 +2044,7 @@
           <a:p>
             <a:fld id="{F0AF5F10-C112-A742-9AF3-53C7C1FC7211}" type="datetimeFigureOut">
               <a:rPr lang="en-US" smtClean="0"/>
-              <a:t>7/2/26</a:t>
+              <a:t>7/15/26</a:t>
             </a:fld>
             <a:endParaRPr lang="en-US"/>
           </a:p>
@@ -2162,7 +2162,7 @@
           <a:p>
             <a:fld id="{F0AF5F10-C112-A742-9AF3-53C7C1FC7211}" type="datetimeFigureOut">
               <a:rPr lang="en-US" smtClean="0"/>
-              <a:t>7/2/26</a:t>
+              <a:t>7/15/26</a:t>
             </a:fld>
             <a:endParaRPr lang="en-US"/>
           </a:p>
@@ -2257,7 +2257,7 @@
           <a:p>
             <a:fld id="{F0AF5F10-C112-A742-9AF3-53C7C1FC7211}" type="datetimeFigureOut">
               <a:rPr lang="en-US" smtClean="0"/>
-              <a:t>7/2/26</a:t>
+              <a:t>7/15/26</a:t>
             </a:fld>
             <a:endParaRPr lang="en-US"/>
           </a:p>
@@ -2534,7 +2534,7 @@
           <a:p>
             <a:fld id="{F0AF5F10-C112-A742-9AF3-53C7C1FC7211}" type="datetimeFigureOut">
               <a:rPr lang="en-US" smtClean="0"/>
-              <a:t>7/2/26</a:t>
+              <a:t>7/15/26</a:t>
             </a:fld>
             <a:endParaRPr lang="en-US"/>
           </a:p>
@@ -2791,7 +2791,7 @@
           <a:p>
             <a:fld id="{F0AF5F10-C112-A742-9AF3-53C7C1FC7211}" type="datetimeFigureOut">
               <a:rPr lang="en-US" smtClean="0"/>
-              <a:t>7/2/26</a:t>
+              <a:t>7/15/26</a:t>
             </a:fld>
             <a:endParaRPr lang="en-US"/>
           </a:p>
@@ -3004,7 +3004,7 @@
           <a:p>
             <a:fld id="{F0AF5F10-C112-A742-9AF3-53C7C1FC7211}" type="datetimeFigureOut">
               <a:rPr lang="en-US" smtClean="0"/>
-              <a:t>7/2/26</a:t>
+              <a:t>7/15/26</a:t>
             </a:fld>
             <a:endParaRPr lang="en-US"/>
           </a:p>
@@ -3498,138 +3498,6 @@
           </a:p>
         </p:txBody>
       </p:sp>
-      <p:grpSp>
-        <p:nvGrpSpPr>
-          <p:cNvPr id="185" name="Group 184">
-            <a:extLst>
-              <a:ext uri="{FF2B5EF4-FFF2-40B4-BE49-F238E27FC236}">
-                <a16:creationId xmlns:a16="http://schemas.microsoft.com/office/drawing/2014/main" id="{5EDF72F5-4CA1-EB11-EC07-F62726459BBB}"/>
-              </a:ext>
-            </a:extLst>
-          </p:cNvPr>
-          <p:cNvGrpSpPr/>
-          <p:nvPr/>
-        </p:nvGrpSpPr>
-        <p:grpSpPr>
-          <a:xfrm>
-            <a:off x="728840" y="243940"/>
-            <a:ext cx="216699" cy="128181"/>
-            <a:chOff x="7196230" y="4833936"/>
-            <a:chExt cx="1441360" cy="852584"/>
-          </a:xfrm>
-        </p:grpSpPr>
-        <p:sp>
-          <p:nvSpPr>
-            <p:cNvPr id="186" name="Rounded Rectangle 185">
-              <a:extLst>
-                <a:ext uri="{FF2B5EF4-FFF2-40B4-BE49-F238E27FC236}">
-                  <a16:creationId xmlns:a16="http://schemas.microsoft.com/office/drawing/2014/main" id="{1F84C208-60AA-7945-42D4-C93BB63B56BA}"/>
-                </a:ext>
-              </a:extLst>
-            </p:cNvPr>
-            <p:cNvSpPr/>
-            <p:nvPr/>
-          </p:nvSpPr>
-          <p:spPr>
-            <a:xfrm>
-              <a:off x="7196230" y="4833936"/>
-              <a:ext cx="1441360" cy="852584"/>
-            </a:xfrm>
-            <a:prstGeom prst="roundRect">
-              <a:avLst>
-                <a:gd name="adj" fmla="val 47948"/>
-              </a:avLst>
-            </a:prstGeom>
-            <a:solidFill>
-              <a:schemeClr val="bg1"/>
-            </a:solidFill>
-            <a:ln w="12700">
-              <a:solidFill>
-                <a:schemeClr val="tx1">
-                  <a:lumMod val="65000"/>
-                  <a:lumOff val="35000"/>
-                </a:schemeClr>
-              </a:solidFill>
-            </a:ln>
-          </p:spPr>
-          <p:style>
-            <a:lnRef idx="2">
-              <a:schemeClr val="accent1">
-                <a:shade val="15000"/>
-              </a:schemeClr>
-            </a:lnRef>
-            <a:fillRef idx="1">
-              <a:schemeClr val="accent1"/>
-            </a:fillRef>
-            <a:effectRef idx="0">
-              <a:schemeClr val="accent1"/>
-            </a:effectRef>
-            <a:fontRef idx="minor">
-              <a:schemeClr val="lt1"/>
-            </a:fontRef>
-          </p:style>
-          <p:txBody>
-            <a:bodyPr rtlCol="0" anchor="ctr"/>
-            <a:lstStyle/>
-            <a:p>
-              <a:pPr algn="ctr"/>
-              <a:endParaRPr lang="en-US" sz="1980" dirty="0"/>
-            </a:p>
-          </p:txBody>
-        </p:sp>
-        <p:sp>
-          <p:nvSpPr>
-            <p:cNvPr id="187" name="Oval 186">
-              <a:extLst>
-                <a:ext uri="{FF2B5EF4-FFF2-40B4-BE49-F238E27FC236}">
-                  <a16:creationId xmlns:a16="http://schemas.microsoft.com/office/drawing/2014/main" id="{36F7E89C-9F1D-47A8-FA81-B9B3DD6164C0}"/>
-                </a:ext>
-              </a:extLst>
-            </p:cNvPr>
-            <p:cNvSpPr/>
-            <p:nvPr/>
-          </p:nvSpPr>
-          <p:spPr>
-            <a:xfrm>
-              <a:off x="7975495" y="5001222"/>
-              <a:ext cx="488623" cy="488623"/>
-            </a:xfrm>
-            <a:prstGeom prst="ellipse">
-              <a:avLst/>
-            </a:prstGeom>
-            <a:noFill/>
-            <a:ln w="19050">
-              <a:solidFill>
-                <a:schemeClr val="accent1"/>
-              </a:solidFill>
-            </a:ln>
-          </p:spPr>
-          <p:style>
-            <a:lnRef idx="2">
-              <a:schemeClr val="accent1">
-                <a:shade val="15000"/>
-              </a:schemeClr>
-            </a:lnRef>
-            <a:fillRef idx="1">
-              <a:schemeClr val="accent1"/>
-            </a:fillRef>
-            <a:effectRef idx="0">
-              <a:schemeClr val="accent1"/>
-            </a:effectRef>
-            <a:fontRef idx="minor">
-              <a:schemeClr val="lt1"/>
-            </a:fontRef>
-          </p:style>
-          <p:txBody>
-            <a:bodyPr rtlCol="0" anchor="ctr"/>
-            <a:lstStyle/>
-            <a:p>
-              <a:pPr algn="ctr"/>
-              <a:endParaRPr lang="en-US" sz="1980" dirty="0"/>
-            </a:p>
-          </p:txBody>
-        </p:sp>
-      </p:grpSp>
       <p:grpSp>
         <p:nvGrpSpPr>
           <p:cNvPr id="197" name="Group 196">
@@ -4160,7 +4028,7 @@
                   </a:schemeClr>
                 </a:solidFill>
                 <a:headEnd type="none" w="med" len="med"/>
-                <a:tailEnd type="arrow" w="med" len="med"/>
+                <a:tailEnd type="triangle" w="med" len="med"/>
               </a:ln>
             </p:spPr>
             <p:style>
@@ -6020,7 +5888,7 @@
                   </a:schemeClr>
                 </a:solidFill>
                 <a:headEnd type="none" w="med" len="med"/>
-                <a:tailEnd type="arrow" w="med" len="med"/>
+                <a:tailEnd type="triangle" w="med" len="med"/>
               </a:ln>
             </p:spPr>
             <p:style>
@@ -6078,7 +5946,7 @@
                 </a:solidFill>
                 <a:miter lim="800000"/>
                 <a:headEnd type="none" w="med" len="lg"/>
-                <a:tailEnd type="stealth" w="med" len="med"/>
+                <a:tailEnd type="triangle" w="med" len="sm"/>
               </a:ln>
             </p:spPr>
             <p:style>
@@ -6136,7 +6004,7 @@
                 </a:solidFill>
                 <a:miter lim="800000"/>
                 <a:headEnd type="none" w="med" len="lg"/>
-                <a:tailEnd type="stealth" w="med" len="med"/>
+                <a:tailEnd type="triangle" w="med" len="sm"/>
               </a:ln>
             </p:spPr>
             <p:style>
@@ -6412,7 +6280,7 @@
                   </a:schemeClr>
                 </a:solidFill>
                 <a:headEnd type="none" w="med" len="med"/>
-                <a:tailEnd type="arrow" w="med" len="med"/>
+                <a:tailEnd type="triangle" w="med" len="med"/>
               </a:ln>
             </p:spPr>
             <p:style>
@@ -12575,169 +12443,148 @@
           </p:style>
         </p:cxnSp>
       </p:grpSp>
-      <p:grpSp>
-        <p:nvGrpSpPr>
-          <p:cNvPr id="326" name="Group 325">
+      <p:cxnSp>
+        <p:nvCxnSpPr>
+          <p:cNvPr id="327" name="Straight Arrow Connector 326">
             <a:extLst>
               <a:ext uri="{FF2B5EF4-FFF2-40B4-BE49-F238E27FC236}">
-                <a16:creationId xmlns:a16="http://schemas.microsoft.com/office/drawing/2014/main" id="{895E002D-DDF6-BC0D-CFE4-3DD9711791AE}"/>
+                <a16:creationId xmlns:a16="http://schemas.microsoft.com/office/drawing/2014/main" id="{3998439F-CCEB-615C-0093-71582B386A36}"/>
               </a:ext>
             </a:extLst>
           </p:cNvPr>
-          <p:cNvGrpSpPr/>
+          <p:cNvCxnSpPr/>
           <p:nvPr/>
-        </p:nvGrpSpPr>
-        <p:grpSpPr>
+        </p:nvCxnSpPr>
+        <p:spPr>
           <a:xfrm>
             <a:off x="2453356" y="316165"/>
-            <a:ext cx="728808" cy="389477"/>
-            <a:chOff x="974960" y="311362"/>
-            <a:chExt cx="728808" cy="389477"/>
+            <a:ext cx="358502" cy="0"/>
           </a:xfrm>
-        </p:grpSpPr>
-        <p:cxnSp>
-          <p:nvCxnSpPr>
-            <p:cNvPr id="327" name="Straight Arrow Connector 326">
-              <a:extLst>
-                <a:ext uri="{FF2B5EF4-FFF2-40B4-BE49-F238E27FC236}">
-                  <a16:creationId xmlns:a16="http://schemas.microsoft.com/office/drawing/2014/main" id="{3998439F-CCEB-615C-0093-71582B386A36}"/>
-                </a:ext>
-              </a:extLst>
-            </p:cNvPr>
-            <p:cNvCxnSpPr/>
-            <p:nvPr/>
-          </p:nvCxnSpPr>
-          <p:spPr>
-            <a:xfrm>
-              <a:off x="974960" y="311362"/>
-              <a:ext cx="358502" cy="0"/>
-            </a:xfrm>
-            <a:prstGeom prst="straightConnector1">
-              <a:avLst/>
-            </a:prstGeom>
-            <a:ln w="19050">
-              <a:solidFill>
-                <a:schemeClr val="tx1">
-                  <a:lumMod val="65000"/>
-                  <a:lumOff val="35000"/>
-                </a:schemeClr>
-              </a:solidFill>
-              <a:prstDash val="solid"/>
-              <a:tailEnd type="triangle"/>
-            </a:ln>
-          </p:spPr>
-          <p:style>
-            <a:lnRef idx="2">
-              <a:schemeClr val="accent1"/>
-            </a:lnRef>
-            <a:fillRef idx="0">
-              <a:schemeClr val="accent1"/>
-            </a:fillRef>
-            <a:effectRef idx="1">
-              <a:schemeClr val="accent1"/>
-            </a:effectRef>
-            <a:fontRef idx="minor">
-              <a:schemeClr val="tx1"/>
-            </a:fontRef>
-          </p:style>
-        </p:cxnSp>
-        <p:cxnSp>
-          <p:nvCxnSpPr>
-            <p:cNvPr id="328" name="Straight Arrow Connector 327">
-              <a:extLst>
-                <a:ext uri="{FF2B5EF4-FFF2-40B4-BE49-F238E27FC236}">
-                  <a16:creationId xmlns:a16="http://schemas.microsoft.com/office/drawing/2014/main" id="{901786A9-AAC6-0B2D-FBE8-AE1FF6426ED8}"/>
-                </a:ext>
-              </a:extLst>
-            </p:cNvPr>
-            <p:cNvCxnSpPr>
-              <a:cxnSpLocks/>
-            </p:cNvCxnSpPr>
-            <p:nvPr/>
-          </p:nvCxnSpPr>
-          <p:spPr>
-            <a:xfrm>
-              <a:off x="1345267" y="375723"/>
-              <a:ext cx="0" cy="247084"/>
-            </a:xfrm>
-            <a:prstGeom prst="straightConnector1">
-              <a:avLst/>
-            </a:prstGeom>
-            <a:ln w="38100">
-              <a:solidFill>
-                <a:schemeClr val="tx1">
-                  <a:lumMod val="65000"/>
-                  <a:lumOff val="35000"/>
-                </a:schemeClr>
-              </a:solidFill>
-              <a:prstDash val="solid"/>
-              <a:tailEnd type="triangle"/>
-            </a:ln>
-          </p:spPr>
-          <p:style>
-            <a:lnRef idx="2">
-              <a:schemeClr val="accent1"/>
-            </a:lnRef>
-            <a:fillRef idx="0">
-              <a:schemeClr val="accent1"/>
-            </a:fillRef>
-            <a:effectRef idx="1">
-              <a:schemeClr val="accent1"/>
-            </a:effectRef>
-            <a:fontRef idx="minor">
-              <a:schemeClr val="tx1"/>
-            </a:fontRef>
-          </p:style>
-        </p:cxnSp>
-        <p:cxnSp>
-          <p:nvCxnSpPr>
-            <p:cNvPr id="329" name="Straight Arrow Connector 328">
-              <a:extLst>
-                <a:ext uri="{FF2B5EF4-FFF2-40B4-BE49-F238E27FC236}">
-                  <a16:creationId xmlns:a16="http://schemas.microsoft.com/office/drawing/2014/main" id="{5B01D928-93A2-06EC-2556-5653B5F49C65}"/>
-                </a:ext>
-              </a:extLst>
-            </p:cNvPr>
-            <p:cNvCxnSpPr>
-              <a:cxnSpLocks/>
-            </p:cNvCxnSpPr>
-            <p:nvPr/>
-          </p:nvCxnSpPr>
-          <p:spPr>
-            <a:xfrm>
-              <a:off x="1345266" y="700839"/>
-              <a:ext cx="358502" cy="0"/>
-            </a:xfrm>
-            <a:prstGeom prst="straightConnector1">
-              <a:avLst/>
-            </a:prstGeom>
-            <a:ln w="19050">
-              <a:solidFill>
-                <a:schemeClr val="tx1">
-                  <a:lumMod val="65000"/>
-                  <a:lumOff val="35000"/>
-                </a:schemeClr>
-              </a:solidFill>
-              <a:prstDash val="dash"/>
-              <a:tailEnd type="triangle"/>
-            </a:ln>
-          </p:spPr>
-          <p:style>
-            <a:lnRef idx="2">
-              <a:schemeClr val="accent1"/>
-            </a:lnRef>
-            <a:fillRef idx="0">
-              <a:schemeClr val="accent1"/>
-            </a:fillRef>
-            <a:effectRef idx="1">
-              <a:schemeClr val="accent1"/>
-            </a:effectRef>
-            <a:fontRef idx="minor">
-              <a:schemeClr val="tx1"/>
-            </a:fontRef>
-          </p:style>
-        </p:cxnSp>
-      </p:grpSp>
+          <a:prstGeom prst="straightConnector1">
+            <a:avLst/>
+          </a:prstGeom>
+          <a:ln w="19050">
+            <a:solidFill>
+              <a:schemeClr val="tx1">
+                <a:lumMod val="65000"/>
+                <a:lumOff val="35000"/>
+              </a:schemeClr>
+            </a:solidFill>
+            <a:prstDash val="solid"/>
+            <a:tailEnd type="triangle"/>
+          </a:ln>
+        </p:spPr>
+        <p:style>
+          <a:lnRef idx="2">
+            <a:schemeClr val="accent1"/>
+          </a:lnRef>
+          <a:fillRef idx="0">
+            <a:schemeClr val="accent1"/>
+          </a:fillRef>
+          <a:effectRef idx="1">
+            <a:schemeClr val="accent1"/>
+          </a:effectRef>
+          <a:fontRef idx="minor">
+            <a:schemeClr val="tx1"/>
+          </a:fontRef>
+        </p:style>
+      </p:cxnSp>
+      <p:cxnSp>
+        <p:nvCxnSpPr>
+          <p:cNvPr id="328" name="Straight Arrow Connector 327">
+            <a:extLst>
+              <a:ext uri="{FF2B5EF4-FFF2-40B4-BE49-F238E27FC236}">
+                <a16:creationId xmlns:a16="http://schemas.microsoft.com/office/drawing/2014/main" id="{901786A9-AAC6-0B2D-FBE8-AE1FF6426ED8}"/>
+              </a:ext>
+            </a:extLst>
+          </p:cNvPr>
+          <p:cNvCxnSpPr>
+            <a:cxnSpLocks/>
+          </p:cNvCxnSpPr>
+          <p:nvPr/>
+        </p:nvCxnSpPr>
+        <p:spPr>
+          <a:xfrm>
+            <a:off x="2823663" y="380526"/>
+            <a:ext cx="0" cy="247084"/>
+          </a:xfrm>
+          <a:prstGeom prst="straightConnector1">
+            <a:avLst/>
+          </a:prstGeom>
+          <a:ln w="38100">
+            <a:solidFill>
+              <a:schemeClr val="tx1">
+                <a:lumMod val="65000"/>
+                <a:lumOff val="35000"/>
+              </a:schemeClr>
+            </a:solidFill>
+            <a:prstDash val="solid"/>
+            <a:tailEnd type="triangle"/>
+          </a:ln>
+        </p:spPr>
+        <p:style>
+          <a:lnRef idx="2">
+            <a:schemeClr val="accent1"/>
+          </a:lnRef>
+          <a:fillRef idx="0">
+            <a:schemeClr val="accent1"/>
+          </a:fillRef>
+          <a:effectRef idx="1">
+            <a:schemeClr val="accent1"/>
+          </a:effectRef>
+          <a:fontRef idx="minor">
+            <a:schemeClr val="tx1"/>
+          </a:fontRef>
+        </p:style>
+      </p:cxnSp>
+      <p:cxnSp>
+        <p:nvCxnSpPr>
+          <p:cNvPr id="329" name="Straight Arrow Connector 328">
+            <a:extLst>
+              <a:ext uri="{FF2B5EF4-FFF2-40B4-BE49-F238E27FC236}">
+                <a16:creationId xmlns:a16="http://schemas.microsoft.com/office/drawing/2014/main" id="{5B01D928-93A2-06EC-2556-5653B5F49C65}"/>
+              </a:ext>
+            </a:extLst>
+          </p:cNvPr>
+          <p:cNvCxnSpPr>
+            <a:cxnSpLocks/>
+          </p:cNvCxnSpPr>
+          <p:nvPr/>
+        </p:nvCxnSpPr>
+        <p:spPr>
+          <a:xfrm>
+            <a:off x="2823662" y="705642"/>
+            <a:ext cx="358502" cy="0"/>
+          </a:xfrm>
+          <a:prstGeom prst="straightConnector1">
+            <a:avLst/>
+          </a:prstGeom>
+          <a:ln w="19050">
+            <a:solidFill>
+              <a:schemeClr val="tx1">
+                <a:lumMod val="65000"/>
+                <a:lumOff val="35000"/>
+              </a:schemeClr>
+            </a:solidFill>
+            <a:prstDash val="dash"/>
+            <a:tailEnd type="triangle"/>
+          </a:ln>
+        </p:spPr>
+        <p:style>
+          <a:lnRef idx="2">
+            <a:schemeClr val="accent1"/>
+          </a:lnRef>
+          <a:fillRef idx="0">
+            <a:schemeClr val="accent1"/>
+          </a:fillRef>
+          <a:effectRef idx="1">
+            <a:schemeClr val="accent1"/>
+          </a:effectRef>
+          <a:fontRef idx="minor">
+            <a:schemeClr val="tx1"/>
+          </a:fontRef>
+        </p:style>
+      </p:cxnSp>
       <p:sp>
         <p:nvSpPr>
           <p:cNvPr id="341" name="TextBox 340">
@@ -12812,6 +12659,282 @@
           </a:p>
         </p:txBody>
       </p:sp>
+      <p:sp>
+        <p:nvSpPr>
+          <p:cNvPr id="7" name="TextBox 6">
+            <a:extLst>
+              <a:ext uri="{FF2B5EF4-FFF2-40B4-BE49-F238E27FC236}">
+                <a16:creationId xmlns:a16="http://schemas.microsoft.com/office/drawing/2014/main" id="{0B57149A-8B18-9D18-A815-4815D2FA952C}"/>
+              </a:ext>
+            </a:extLst>
+          </p:cNvPr>
+          <p:cNvSpPr txBox="1"/>
+          <p:nvPr/>
+        </p:nvSpPr>
+        <p:spPr>
+          <a:xfrm>
+            <a:off x="682724" y="594578"/>
+            <a:ext cx="466795" cy="215444"/>
+          </a:xfrm>
+          <a:prstGeom prst="rect">
+            <a:avLst/>
+          </a:prstGeom>
+          <a:noFill/>
+        </p:spPr>
+        <p:txBody>
+          <a:bodyPr wrap="none" rtlCol="0">
+            <a:spAutoFit/>
+          </a:bodyPr>
+          <a:lstStyle/>
+          <a:p>
+            <a:pPr algn="ctr"/>
+            <a:r>
+              <a:rPr lang="en-US" sz="800" dirty="0">
+                <a:latin typeface="Helvetica" pitchFamily="2" charset="0"/>
+              </a:rPr>
+              <a:t>host 2</a:t>
+            </a:r>
+          </a:p>
+        </p:txBody>
+      </p:sp>
+      <p:sp>
+        <p:nvSpPr>
+          <p:cNvPr id="16" name="TextBox 15">
+            <a:extLst>
+              <a:ext uri="{FF2B5EF4-FFF2-40B4-BE49-F238E27FC236}">
+                <a16:creationId xmlns:a16="http://schemas.microsoft.com/office/drawing/2014/main" id="{64270F1D-1347-3458-D942-A011DF0E61EE}"/>
+              </a:ext>
+            </a:extLst>
+          </p:cNvPr>
+          <p:cNvSpPr txBox="1"/>
+          <p:nvPr/>
+        </p:nvSpPr>
+        <p:spPr>
+          <a:xfrm>
+            <a:off x="299430" y="204566"/>
+            <a:ext cx="475666" cy="215444"/>
+          </a:xfrm>
+          <a:prstGeom prst="rect">
+            <a:avLst/>
+          </a:prstGeom>
+          <a:noFill/>
+        </p:spPr>
+        <p:txBody>
+          <a:bodyPr wrap="square" rtlCol="0">
+            <a:spAutoFit/>
+          </a:bodyPr>
+          <a:lstStyle/>
+          <a:p>
+            <a:pPr algn="ctr"/>
+            <a:r>
+              <a:rPr lang="en-US" sz="800" dirty="0">
+                <a:latin typeface="Helvetica" pitchFamily="2" charset="0"/>
+              </a:rPr>
+              <a:t>host 1</a:t>
+            </a:r>
+          </a:p>
+        </p:txBody>
+      </p:sp>
+      <p:grpSp>
+        <p:nvGrpSpPr>
+          <p:cNvPr id="63" name="Group 62">
+            <a:extLst>
+              <a:ext uri="{FF2B5EF4-FFF2-40B4-BE49-F238E27FC236}">
+                <a16:creationId xmlns:a16="http://schemas.microsoft.com/office/drawing/2014/main" id="{DAFE4687-86DE-4735-7209-09FCDBD16D4E}"/>
+              </a:ext>
+            </a:extLst>
+          </p:cNvPr>
+          <p:cNvGrpSpPr/>
+          <p:nvPr/>
+        </p:nvGrpSpPr>
+        <p:grpSpPr>
+          <a:xfrm>
+            <a:off x="655889" y="40576"/>
+            <a:ext cx="362600" cy="332843"/>
+            <a:chOff x="655889" y="39278"/>
+            <a:chExt cx="362600" cy="332843"/>
+          </a:xfrm>
+        </p:grpSpPr>
+        <p:grpSp>
+          <p:nvGrpSpPr>
+            <p:cNvPr id="185" name="Group 184">
+              <a:extLst>
+                <a:ext uri="{FF2B5EF4-FFF2-40B4-BE49-F238E27FC236}">
+                  <a16:creationId xmlns:a16="http://schemas.microsoft.com/office/drawing/2014/main" id="{5EDF72F5-4CA1-EB11-EC07-F62726459BBB}"/>
+                </a:ext>
+              </a:extLst>
+            </p:cNvPr>
+            <p:cNvGrpSpPr/>
+            <p:nvPr/>
+          </p:nvGrpSpPr>
+          <p:grpSpPr>
+            <a:xfrm>
+              <a:off x="728840" y="243940"/>
+              <a:ext cx="216699" cy="128181"/>
+              <a:chOff x="7196230" y="4833936"/>
+              <a:chExt cx="1441360" cy="852584"/>
+            </a:xfrm>
+          </p:grpSpPr>
+          <p:sp>
+            <p:nvSpPr>
+              <p:cNvPr id="186" name="Rounded Rectangle 185">
+                <a:extLst>
+                  <a:ext uri="{FF2B5EF4-FFF2-40B4-BE49-F238E27FC236}">
+                    <a16:creationId xmlns:a16="http://schemas.microsoft.com/office/drawing/2014/main" id="{1F84C208-60AA-7945-42D4-C93BB63B56BA}"/>
+                  </a:ext>
+                </a:extLst>
+              </p:cNvPr>
+              <p:cNvSpPr/>
+              <p:nvPr/>
+            </p:nvSpPr>
+            <p:spPr>
+              <a:xfrm>
+                <a:off x="7196230" y="4833936"/>
+                <a:ext cx="1441360" cy="852584"/>
+              </a:xfrm>
+              <a:prstGeom prst="roundRect">
+                <a:avLst>
+                  <a:gd name="adj" fmla="val 47948"/>
+                </a:avLst>
+              </a:prstGeom>
+              <a:solidFill>
+                <a:schemeClr val="bg1"/>
+              </a:solidFill>
+              <a:ln w="12700">
+                <a:solidFill>
+                  <a:schemeClr val="tx1">
+                    <a:lumMod val="65000"/>
+                    <a:lumOff val="35000"/>
+                  </a:schemeClr>
+                </a:solidFill>
+              </a:ln>
+            </p:spPr>
+            <p:style>
+              <a:lnRef idx="2">
+                <a:schemeClr val="accent1">
+                  <a:shade val="15000"/>
+                </a:schemeClr>
+              </a:lnRef>
+              <a:fillRef idx="1">
+                <a:schemeClr val="accent1"/>
+              </a:fillRef>
+              <a:effectRef idx="0">
+                <a:schemeClr val="accent1"/>
+              </a:effectRef>
+              <a:fontRef idx="minor">
+                <a:schemeClr val="lt1"/>
+              </a:fontRef>
+            </p:style>
+            <p:txBody>
+              <a:bodyPr rtlCol="0" anchor="ctr"/>
+              <a:lstStyle/>
+              <a:p>
+                <a:pPr algn="ctr"/>
+                <a:endParaRPr lang="en-US" sz="1980" dirty="0"/>
+              </a:p>
+            </p:txBody>
+          </p:sp>
+          <p:sp>
+            <p:nvSpPr>
+              <p:cNvPr id="187" name="Oval 186">
+                <a:extLst>
+                  <a:ext uri="{FF2B5EF4-FFF2-40B4-BE49-F238E27FC236}">
+                    <a16:creationId xmlns:a16="http://schemas.microsoft.com/office/drawing/2014/main" id="{36F7E89C-9F1D-47A8-FA81-B9B3DD6164C0}"/>
+                  </a:ext>
+                </a:extLst>
+              </p:cNvPr>
+              <p:cNvSpPr/>
+              <p:nvPr/>
+            </p:nvSpPr>
+            <p:spPr>
+              <a:xfrm>
+                <a:off x="7975495" y="5001222"/>
+                <a:ext cx="488623" cy="488623"/>
+              </a:xfrm>
+              <a:prstGeom prst="ellipse">
+                <a:avLst/>
+              </a:prstGeom>
+              <a:noFill/>
+              <a:ln w="19050">
+                <a:solidFill>
+                  <a:schemeClr val="accent1"/>
+                </a:solidFill>
+              </a:ln>
+            </p:spPr>
+            <p:style>
+              <a:lnRef idx="2">
+                <a:schemeClr val="accent1">
+                  <a:shade val="15000"/>
+                </a:schemeClr>
+              </a:lnRef>
+              <a:fillRef idx="1">
+                <a:schemeClr val="accent1"/>
+              </a:fillRef>
+              <a:effectRef idx="0">
+                <a:schemeClr val="accent1"/>
+              </a:effectRef>
+              <a:fontRef idx="minor">
+                <a:schemeClr val="lt1"/>
+              </a:fontRef>
+            </p:style>
+            <p:txBody>
+              <a:bodyPr rtlCol="0" anchor="ctr"/>
+              <a:lstStyle/>
+              <a:p>
+                <a:pPr algn="ctr"/>
+                <a:endParaRPr lang="en-US" sz="1980" dirty="0"/>
+              </a:p>
+            </p:txBody>
+          </p:sp>
+        </p:grpSp>
+        <p:sp>
+          <p:nvSpPr>
+            <p:cNvPr id="17" name="TextBox 16">
+              <a:extLst>
+                <a:ext uri="{FF2B5EF4-FFF2-40B4-BE49-F238E27FC236}">
+                  <a16:creationId xmlns:a16="http://schemas.microsoft.com/office/drawing/2014/main" id="{335A5DA6-7938-A8E0-9EE7-71A8E9AE939D}"/>
+                </a:ext>
+              </a:extLst>
+            </p:cNvPr>
+            <p:cNvSpPr txBox="1"/>
+            <p:nvPr/>
+          </p:nvSpPr>
+          <p:spPr>
+            <a:xfrm>
+              <a:off x="655889" y="39278"/>
+              <a:ext cx="362600" cy="215444"/>
+            </a:xfrm>
+            <a:prstGeom prst="rect">
+              <a:avLst/>
+            </a:prstGeom>
+            <a:noFill/>
+          </p:spPr>
+          <p:txBody>
+            <a:bodyPr wrap="none" rtlCol="0">
+              <a:spAutoFit/>
+            </a:bodyPr>
+            <a:lstStyle/>
+            <a:p>
+              <a:pPr algn="ctr"/>
+              <a:r>
+                <a:rPr lang="en-US" sz="800" dirty="0" err="1">
+                  <a:solidFill>
+                    <a:schemeClr val="accent1"/>
+                  </a:solidFill>
+                  <a:latin typeface="Helvetica" pitchFamily="2" charset="0"/>
+                </a:rPr>
+                <a:t>Anc</a:t>
+              </a:r>
+              <a:endParaRPr lang="en-US" sz="800" dirty="0">
+                <a:solidFill>
+                  <a:schemeClr val="accent1"/>
+                </a:solidFill>
+                <a:latin typeface="Helvetica" pitchFamily="2" charset="0"/>
+              </a:endParaRPr>
+            </a:p>
+          </p:txBody>
+        </p:sp>
+      </p:grpSp>
       <p:grpSp>
         <p:nvGrpSpPr>
           <p:cNvPr id="2" name="Group 1">
@@ -12855,7 +12978,9 @@
               </a:avLst>
             </a:prstGeom>
             <a:solidFill>
-              <a:schemeClr val="bg1"/>
+              <a:schemeClr val="bg1">
+                <a:lumMod val="85000"/>
+              </a:schemeClr>
             </a:solidFill>
             <a:ln w="12700">
               <a:solidFill>
@@ -12944,170 +13069,248 @@
           </p:txBody>
         </p:sp>
       </p:grpSp>
-      <p:sp>
-        <p:nvSpPr>
-          <p:cNvPr id="7" name="TextBox 6">
+      <p:grpSp>
+        <p:nvGrpSpPr>
+          <p:cNvPr id="56" name="Group 55">
             <a:extLst>
               <a:ext uri="{FF2B5EF4-FFF2-40B4-BE49-F238E27FC236}">
-                <a16:creationId xmlns:a16="http://schemas.microsoft.com/office/drawing/2014/main" id="{0B57149A-8B18-9D18-A815-4815D2FA952C}"/>
+                <a16:creationId xmlns:a16="http://schemas.microsoft.com/office/drawing/2014/main" id="{1B032CD8-8CE6-7FB9-984B-F1E305105055}"/>
               </a:ext>
             </a:extLst>
           </p:cNvPr>
-          <p:cNvSpPr txBox="1"/>
+          <p:cNvGrpSpPr/>
           <p:nvPr/>
-        </p:nvSpPr>
-        <p:spPr>
+        </p:nvGrpSpPr>
+        <p:grpSpPr>
           <a:xfrm>
-            <a:off x="682724" y="594578"/>
-            <a:ext cx="466795" cy="215444"/>
+            <a:off x="3139145" y="55551"/>
+            <a:ext cx="356188" cy="302893"/>
+            <a:chOff x="3149794" y="456495"/>
+            <a:chExt cx="356188" cy="302893"/>
           </a:xfrm>
-          <a:prstGeom prst="rect">
-            <a:avLst/>
-          </a:prstGeom>
-          <a:noFill/>
-        </p:spPr>
-        <p:txBody>
-          <a:bodyPr wrap="none" rtlCol="0">
-            <a:spAutoFit/>
-          </a:bodyPr>
-          <a:lstStyle/>
-          <a:p>
-            <a:pPr algn="ctr"/>
-            <a:r>
-              <a:rPr lang="en-US" sz="800" dirty="0">
-                <a:latin typeface="Helvetica" pitchFamily="2" charset="0"/>
-              </a:rPr>
-              <a:t>host 2</a:t>
-            </a:r>
-          </a:p>
-        </p:txBody>
-      </p:sp>
-      <p:sp>
-        <p:nvSpPr>
-          <p:cNvPr id="16" name="TextBox 15">
+        </p:grpSpPr>
+        <p:grpSp>
+          <p:nvGrpSpPr>
+            <p:cNvPr id="57" name="Group 56">
+              <a:extLst>
+                <a:ext uri="{FF2B5EF4-FFF2-40B4-BE49-F238E27FC236}">
+                  <a16:creationId xmlns:a16="http://schemas.microsoft.com/office/drawing/2014/main" id="{0E72422A-044C-0156-39B2-54D0B560526D}"/>
+                </a:ext>
+              </a:extLst>
+            </p:cNvPr>
+            <p:cNvGrpSpPr/>
+            <p:nvPr/>
+          </p:nvGrpSpPr>
+          <p:grpSpPr>
+            <a:xfrm>
+              <a:off x="3210731" y="631207"/>
+              <a:ext cx="216699" cy="128181"/>
+              <a:chOff x="7196230" y="4833936"/>
+              <a:chExt cx="1441360" cy="852584"/>
+            </a:xfrm>
+          </p:grpSpPr>
+          <p:sp>
+            <p:nvSpPr>
+              <p:cNvPr id="59" name="Rounded Rectangle 58">
+                <a:extLst>
+                  <a:ext uri="{FF2B5EF4-FFF2-40B4-BE49-F238E27FC236}">
+                    <a16:creationId xmlns:a16="http://schemas.microsoft.com/office/drawing/2014/main" id="{1CDC26D7-8B7B-DFB2-8D3D-A5DA69DB7597}"/>
+                  </a:ext>
+                </a:extLst>
+              </p:cNvPr>
+              <p:cNvSpPr/>
+              <p:nvPr/>
+            </p:nvSpPr>
+            <p:spPr>
+              <a:xfrm>
+                <a:off x="7196230" y="4833936"/>
+                <a:ext cx="1441360" cy="852584"/>
+              </a:xfrm>
+              <a:prstGeom prst="roundRect">
+                <a:avLst>
+                  <a:gd name="adj" fmla="val 47948"/>
+                </a:avLst>
+              </a:prstGeom>
+              <a:solidFill>
+                <a:schemeClr val="bg1"/>
+              </a:solidFill>
+              <a:ln w="12700">
+                <a:solidFill>
+                  <a:schemeClr val="tx1">
+                    <a:lumMod val="65000"/>
+                    <a:lumOff val="35000"/>
+                  </a:schemeClr>
+                </a:solidFill>
+              </a:ln>
+            </p:spPr>
+            <p:style>
+              <a:lnRef idx="2">
+                <a:schemeClr val="accent1">
+                  <a:shade val="15000"/>
+                </a:schemeClr>
+              </a:lnRef>
+              <a:fillRef idx="1">
+                <a:schemeClr val="accent1"/>
+              </a:fillRef>
+              <a:effectRef idx="0">
+                <a:schemeClr val="accent1"/>
+              </a:effectRef>
+              <a:fontRef idx="minor">
+                <a:schemeClr val="lt1"/>
+              </a:fontRef>
+            </p:style>
+            <p:txBody>
+              <a:bodyPr rtlCol="0" anchor="ctr"/>
+              <a:lstStyle/>
+              <a:p>
+                <a:pPr algn="ctr"/>
+                <a:endParaRPr lang="en-US" sz="1980" dirty="0"/>
+              </a:p>
+            </p:txBody>
+          </p:sp>
+          <p:sp>
+            <p:nvSpPr>
+              <p:cNvPr id="60" name="Oval 59">
+                <a:extLst>
+                  <a:ext uri="{FF2B5EF4-FFF2-40B4-BE49-F238E27FC236}">
+                    <a16:creationId xmlns:a16="http://schemas.microsoft.com/office/drawing/2014/main" id="{590DAB9D-D755-6A21-5D4E-90C43C5D3E8D}"/>
+                  </a:ext>
+                </a:extLst>
+              </p:cNvPr>
+              <p:cNvSpPr/>
+              <p:nvPr/>
+            </p:nvSpPr>
+            <p:spPr>
+              <a:xfrm>
+                <a:off x="7975493" y="5026880"/>
+                <a:ext cx="488621" cy="488626"/>
+              </a:xfrm>
+              <a:prstGeom prst="ellipse">
+                <a:avLst/>
+              </a:prstGeom>
+              <a:noFill/>
+              <a:ln w="19050">
+                <a:solidFill>
+                  <a:schemeClr val="accent2"/>
+                </a:solidFill>
+              </a:ln>
+            </p:spPr>
+            <p:style>
+              <a:lnRef idx="2">
+                <a:schemeClr val="accent1">
+                  <a:shade val="15000"/>
+                </a:schemeClr>
+              </a:lnRef>
+              <a:fillRef idx="1">
+                <a:schemeClr val="accent1"/>
+              </a:fillRef>
+              <a:effectRef idx="0">
+                <a:schemeClr val="accent1"/>
+              </a:effectRef>
+              <a:fontRef idx="minor">
+                <a:schemeClr val="lt1"/>
+              </a:fontRef>
+            </p:style>
+            <p:txBody>
+              <a:bodyPr rtlCol="0" anchor="ctr"/>
+              <a:lstStyle/>
+              <a:p>
+                <a:pPr algn="ctr"/>
+                <a:endParaRPr lang="en-US" sz="1980" dirty="0"/>
+              </a:p>
+            </p:txBody>
+          </p:sp>
+        </p:grpSp>
+        <p:sp>
+          <p:nvSpPr>
+            <p:cNvPr id="58" name="TextBox 57">
+              <a:extLst>
+                <a:ext uri="{FF2B5EF4-FFF2-40B4-BE49-F238E27FC236}">
+                  <a16:creationId xmlns:a16="http://schemas.microsoft.com/office/drawing/2014/main" id="{3B8121E9-510D-DB81-0DDA-A853B80071D1}"/>
+                </a:ext>
+              </a:extLst>
+            </p:cNvPr>
+            <p:cNvSpPr txBox="1"/>
+            <p:nvPr/>
+          </p:nvSpPr>
+          <p:spPr>
+            <a:xfrm>
+              <a:off x="3149794" y="456495"/>
+              <a:ext cx="356188" cy="215444"/>
+            </a:xfrm>
+            <a:prstGeom prst="rect">
+              <a:avLst/>
+            </a:prstGeom>
+            <a:noFill/>
+          </p:spPr>
+          <p:txBody>
+            <a:bodyPr wrap="none" rtlCol="0">
+              <a:spAutoFit/>
+            </a:bodyPr>
+            <a:lstStyle/>
+            <a:p>
+              <a:pPr algn="ctr"/>
+              <a:r>
+                <a:rPr lang="en-US" sz="800" dirty="0">
+                  <a:solidFill>
+                    <a:schemeClr val="accent2"/>
+                  </a:solidFill>
+                  <a:latin typeface="Helvetica" pitchFamily="2" charset="0"/>
+                </a:rPr>
+                <a:t>Mut</a:t>
+              </a:r>
+            </a:p>
+          </p:txBody>
+        </p:sp>
+      </p:grpSp>
+      <p:cxnSp>
+        <p:nvCxnSpPr>
+          <p:cNvPr id="61" name="Straight Arrow Connector 60">
             <a:extLst>
               <a:ext uri="{FF2B5EF4-FFF2-40B4-BE49-F238E27FC236}">
-                <a16:creationId xmlns:a16="http://schemas.microsoft.com/office/drawing/2014/main" id="{64270F1D-1347-3458-D942-A011DF0E61EE}"/>
+                <a16:creationId xmlns:a16="http://schemas.microsoft.com/office/drawing/2014/main" id="{38184A56-31B1-4E93-74C4-3AAFBC73E33A}"/>
               </a:ext>
             </a:extLst>
           </p:cNvPr>
-          <p:cNvSpPr txBox="1"/>
+          <p:cNvCxnSpPr>
+            <a:cxnSpLocks/>
+          </p:cNvCxnSpPr>
           <p:nvPr/>
-        </p:nvSpPr>
+        </p:nvCxnSpPr>
         <p:spPr>
-          <a:xfrm>
-            <a:off x="299430" y="204566"/>
-            <a:ext cx="475666" cy="215444"/>
+          <a:xfrm flipV="1">
+            <a:off x="3320084" y="398940"/>
+            <a:ext cx="0" cy="181545"/>
           </a:xfrm>
-          <a:prstGeom prst="rect">
+          <a:prstGeom prst="straightConnector1">
             <a:avLst/>
           </a:prstGeom>
-          <a:noFill/>
+          <a:ln w="38100">
+            <a:solidFill>
+              <a:schemeClr val="tx1">
+                <a:lumMod val="65000"/>
+                <a:lumOff val="35000"/>
+              </a:schemeClr>
+            </a:solidFill>
+            <a:prstDash val="solid"/>
+            <a:tailEnd type="triangle"/>
+          </a:ln>
         </p:spPr>
-        <p:txBody>
-          <a:bodyPr wrap="square" rtlCol="0">
-            <a:spAutoFit/>
-          </a:bodyPr>
-          <a:lstStyle/>
-          <a:p>
-            <a:pPr algn="ctr"/>
-            <a:r>
-              <a:rPr lang="en-US" sz="800" dirty="0">
-                <a:latin typeface="Helvetica" pitchFamily="2" charset="0"/>
-              </a:rPr>
-              <a:t>host 1</a:t>
-            </a:r>
-          </a:p>
-        </p:txBody>
-      </p:sp>
-      <p:sp>
-        <p:nvSpPr>
-          <p:cNvPr id="17" name="TextBox 16">
-            <a:extLst>
-              <a:ext uri="{FF2B5EF4-FFF2-40B4-BE49-F238E27FC236}">
-                <a16:creationId xmlns:a16="http://schemas.microsoft.com/office/drawing/2014/main" id="{335A5DA6-7938-A8E0-9EE7-71A8E9AE939D}"/>
-              </a:ext>
-            </a:extLst>
-          </p:cNvPr>
-          <p:cNvSpPr txBox="1"/>
-          <p:nvPr/>
-        </p:nvSpPr>
-        <p:spPr>
-          <a:xfrm>
-            <a:off x="655889" y="39278"/>
-            <a:ext cx="362600" cy="215444"/>
-          </a:xfrm>
-          <a:prstGeom prst="rect">
-            <a:avLst/>
-          </a:prstGeom>
-          <a:noFill/>
-        </p:spPr>
-        <p:txBody>
-          <a:bodyPr wrap="none" rtlCol="0">
-            <a:spAutoFit/>
-          </a:bodyPr>
-          <a:lstStyle/>
-          <a:p>
-            <a:pPr algn="ctr"/>
-            <a:r>
-              <a:rPr lang="en-US" sz="800" dirty="0" err="1">
-                <a:solidFill>
-                  <a:schemeClr val="accent1"/>
-                </a:solidFill>
-                <a:latin typeface="Helvetica" pitchFamily="2" charset="0"/>
-              </a:rPr>
-              <a:t>Anc</a:t>
-            </a:r>
-            <a:endParaRPr lang="en-US" sz="800" dirty="0">
-              <a:solidFill>
-                <a:schemeClr val="accent1"/>
-              </a:solidFill>
-              <a:latin typeface="Helvetica" pitchFamily="2" charset="0"/>
-            </a:endParaRPr>
-          </a:p>
-        </p:txBody>
-      </p:sp>
-      <p:sp>
-        <p:nvSpPr>
-          <p:cNvPr id="18" name="TextBox 17">
-            <a:extLst>
-              <a:ext uri="{FF2B5EF4-FFF2-40B4-BE49-F238E27FC236}">
-                <a16:creationId xmlns:a16="http://schemas.microsoft.com/office/drawing/2014/main" id="{EBFCC3A9-864E-AB3F-0E47-C84C790D9D60}"/>
-              </a:ext>
-            </a:extLst>
-          </p:cNvPr>
-          <p:cNvSpPr txBox="1"/>
-          <p:nvPr/>
-        </p:nvSpPr>
-        <p:spPr>
-          <a:xfrm>
-            <a:off x="3149794" y="456495"/>
-            <a:ext cx="356188" cy="215444"/>
-          </a:xfrm>
-          <a:prstGeom prst="rect">
-            <a:avLst/>
-          </a:prstGeom>
-          <a:noFill/>
-        </p:spPr>
-        <p:txBody>
-          <a:bodyPr wrap="none" rtlCol="0">
-            <a:spAutoFit/>
-          </a:bodyPr>
-          <a:lstStyle/>
-          <a:p>
-            <a:pPr algn="ctr"/>
-            <a:r>
-              <a:rPr lang="en-US" sz="800" dirty="0">
-                <a:solidFill>
-                  <a:schemeClr val="accent2"/>
-                </a:solidFill>
-                <a:latin typeface="Helvetica" pitchFamily="2" charset="0"/>
-              </a:rPr>
-              <a:t>Mut</a:t>
-            </a:r>
-          </a:p>
-        </p:txBody>
-      </p:sp>
+        <p:style>
+          <a:lnRef idx="2">
+            <a:schemeClr val="accent1"/>
+          </a:lnRef>
+          <a:fillRef idx="0">
+            <a:schemeClr val="accent1"/>
+          </a:fillRef>
+          <a:effectRef idx="1">
+            <a:schemeClr val="accent1"/>
+          </a:effectRef>
+          <a:fontRef idx="minor">
+            <a:schemeClr val="tx1"/>
+          </a:fontRef>
+        </p:style>
+      </p:cxnSp>
     </p:spTree>
     <p:extLst>
       <p:ext uri="{BB962C8B-B14F-4D97-AF65-F5344CB8AC3E}">

</xml_diff>